<commit_message>
update arrow colors to highlight directions
</commit_message>
<xml_diff>
--- a/downloads/group/interdisciplinary_framework.pptx
+++ b/downloads/group/interdisciplinary_framework.pptx
@@ -128,18 +128,18 @@
   <pc:docChgLst>
     <pc:chgData name="Fei Yao" userId="0f76fc2f-86db-4f00-832a-b92dc6cb86c5" providerId="ADAL" clId="{3542449D-0F28-5F63-A95F-E350D95EFEF5}"/>
     <pc:docChg chg="custSel delSld modSld modMainMaster modNotesMaster">
-      <pc:chgData name="Fei Yao" userId="0f76fc2f-86db-4f00-832a-b92dc6cb86c5" providerId="ADAL" clId="{3542449D-0F28-5F63-A95F-E350D95EFEF5}" dt="2026-01-17T17:27:34.718" v="324" actId="20577"/>
+      <pc:chgData name="Fei Yao" userId="0f76fc2f-86db-4f00-832a-b92dc6cb86c5" providerId="ADAL" clId="{3542449D-0F28-5F63-A95F-E350D95EFEF5}" dt="2026-01-18T10:23:14.892" v="337" actId="207"/>
       <pc:docMkLst>
         <pc:docMk/>
       </pc:docMkLst>
       <pc:sldChg chg="addSp delSp modSp mod modNotes">
-        <pc:chgData name="Fei Yao" userId="0f76fc2f-86db-4f00-832a-b92dc6cb86c5" providerId="ADAL" clId="{3542449D-0F28-5F63-A95F-E350D95EFEF5}" dt="2026-01-17T17:27:34.718" v="324" actId="20577"/>
+        <pc:chgData name="Fei Yao" userId="0f76fc2f-86db-4f00-832a-b92dc6cb86c5" providerId="ADAL" clId="{3542449D-0F28-5F63-A95F-E350D95EFEF5}" dt="2026-01-18T10:23:14.892" v="337" actId="207"/>
         <pc:sldMkLst>
           <pc:docMk/>
           <pc:sldMk cId="4040458237" sldId="257"/>
         </pc:sldMkLst>
         <pc:spChg chg="mod">
-          <ac:chgData name="Fei Yao" userId="0f76fc2f-86db-4f00-832a-b92dc6cb86c5" providerId="ADAL" clId="{3542449D-0F28-5F63-A95F-E350D95EFEF5}" dt="2026-01-17T17:05:07.571" v="61" actId="207"/>
+          <ac:chgData name="Fei Yao" userId="0f76fc2f-86db-4f00-832a-b92dc6cb86c5" providerId="ADAL" clId="{3542449D-0F28-5F63-A95F-E350D95EFEF5}" dt="2026-01-18T10:23:14.892" v="337" actId="207"/>
           <ac:spMkLst>
             <pc:docMk/>
             <pc:sldMk cId="4040458237" sldId="257"/>
@@ -147,7 +147,7 @@
           </ac:spMkLst>
         </pc:spChg>
         <pc:spChg chg="mod">
-          <ac:chgData name="Fei Yao" userId="0f76fc2f-86db-4f00-832a-b92dc6cb86c5" providerId="ADAL" clId="{3542449D-0F28-5F63-A95F-E350D95EFEF5}" dt="2026-01-17T17:05:07.571" v="61" actId="207"/>
+          <ac:chgData name="Fei Yao" userId="0f76fc2f-86db-4f00-832a-b92dc6cb86c5" providerId="ADAL" clId="{3542449D-0F28-5F63-A95F-E350D95EFEF5}" dt="2026-01-18T10:23:14.892" v="337" actId="207"/>
           <ac:spMkLst>
             <pc:docMk/>
             <pc:sldMk cId="4040458237" sldId="257"/>
@@ -155,7 +155,7 @@
           </ac:spMkLst>
         </pc:spChg>
         <pc:spChg chg="mod">
-          <ac:chgData name="Fei Yao" userId="0f76fc2f-86db-4f00-832a-b92dc6cb86c5" providerId="ADAL" clId="{3542449D-0F28-5F63-A95F-E350D95EFEF5}" dt="2026-01-17T17:05:07.571" v="61" actId="207"/>
+          <ac:chgData name="Fei Yao" userId="0f76fc2f-86db-4f00-832a-b92dc6cb86c5" providerId="ADAL" clId="{3542449D-0F28-5F63-A95F-E350D95EFEF5}" dt="2026-01-18T10:22:59.697" v="336" actId="207"/>
           <ac:spMkLst>
             <pc:docMk/>
             <pc:sldMk cId="4040458237" sldId="257"/>
@@ -163,7 +163,7 @@
           </ac:spMkLst>
         </pc:spChg>
         <pc:spChg chg="mod topLvl">
-          <ac:chgData name="Fei Yao" userId="0f76fc2f-86db-4f00-832a-b92dc6cb86c5" providerId="ADAL" clId="{3542449D-0F28-5F63-A95F-E350D95EFEF5}" dt="2026-01-17T17:19:35.749" v="305" actId="164"/>
+          <ac:chgData name="Fei Yao" userId="0f76fc2f-86db-4f00-832a-b92dc6cb86c5" providerId="ADAL" clId="{3542449D-0F28-5F63-A95F-E350D95EFEF5}" dt="2026-01-18T10:17:29.544" v="335" actId="1582"/>
           <ac:spMkLst>
             <pc:docMk/>
             <pc:sldMk cId="4040458237" sldId="257"/>
@@ -1110,7 +1110,7 @@
           <a:p>
             <a:fld id="{2D5B012D-04D8-C041-B97B-CC7FDEBE0565}" type="datetimeFigureOut">
               <a:rPr lang="en-US" smtClean="0"/>
-              <a:t>1/17/26</a:t>
+              <a:t>1/18/26</a:t>
             </a:fld>
             <a:endParaRPr lang="en-US"/>
           </a:p>
@@ -1598,7 +1598,7 @@
           <a:p>
             <a:fld id="{D1C87F3C-6FA4-D54F-AEDE-BC3ADE73DCD6}" type="datetimeFigureOut">
               <a:rPr lang="en-US" smtClean="0"/>
-              <a:t>1/17/26</a:t>
+              <a:t>1/18/26</a:t>
             </a:fld>
             <a:endParaRPr lang="en-US"/>
           </a:p>
@@ -1768,7 +1768,7 @@
           <a:p>
             <a:fld id="{D1C87F3C-6FA4-D54F-AEDE-BC3ADE73DCD6}" type="datetimeFigureOut">
               <a:rPr lang="en-US" smtClean="0"/>
-              <a:t>1/17/26</a:t>
+              <a:t>1/18/26</a:t>
             </a:fld>
             <a:endParaRPr lang="en-US"/>
           </a:p>
@@ -1948,7 +1948,7 @@
           <a:p>
             <a:fld id="{D1C87F3C-6FA4-D54F-AEDE-BC3ADE73DCD6}" type="datetimeFigureOut">
               <a:rPr lang="en-US" smtClean="0"/>
-              <a:t>1/17/26</a:t>
+              <a:t>1/18/26</a:t>
             </a:fld>
             <a:endParaRPr lang="en-US"/>
           </a:p>
@@ -2118,7 +2118,7 @@
           <a:p>
             <a:fld id="{D1C87F3C-6FA4-D54F-AEDE-BC3ADE73DCD6}" type="datetimeFigureOut">
               <a:rPr lang="en-US" smtClean="0"/>
-              <a:t>1/17/26</a:t>
+              <a:t>1/18/26</a:t>
             </a:fld>
             <a:endParaRPr lang="en-US"/>
           </a:p>
@@ -2364,7 +2364,7 @@
           <a:p>
             <a:fld id="{D1C87F3C-6FA4-D54F-AEDE-BC3ADE73DCD6}" type="datetimeFigureOut">
               <a:rPr lang="en-US" smtClean="0"/>
-              <a:t>1/17/26</a:t>
+              <a:t>1/18/26</a:t>
             </a:fld>
             <a:endParaRPr lang="en-US"/>
           </a:p>
@@ -2596,7 +2596,7 @@
           <a:p>
             <a:fld id="{D1C87F3C-6FA4-D54F-AEDE-BC3ADE73DCD6}" type="datetimeFigureOut">
               <a:rPr lang="en-US" smtClean="0"/>
-              <a:t>1/17/26</a:t>
+              <a:t>1/18/26</a:t>
             </a:fld>
             <a:endParaRPr lang="en-US"/>
           </a:p>
@@ -2963,7 +2963,7 @@
           <a:p>
             <a:fld id="{D1C87F3C-6FA4-D54F-AEDE-BC3ADE73DCD6}" type="datetimeFigureOut">
               <a:rPr lang="en-US" smtClean="0"/>
-              <a:t>1/17/26</a:t>
+              <a:t>1/18/26</a:t>
             </a:fld>
             <a:endParaRPr lang="en-US"/>
           </a:p>
@@ -3081,7 +3081,7 @@
           <a:p>
             <a:fld id="{D1C87F3C-6FA4-D54F-AEDE-BC3ADE73DCD6}" type="datetimeFigureOut">
               <a:rPr lang="en-US" smtClean="0"/>
-              <a:t>1/17/26</a:t>
+              <a:t>1/18/26</a:t>
             </a:fld>
             <a:endParaRPr lang="en-US"/>
           </a:p>
@@ -3176,7 +3176,7 @@
           <a:p>
             <a:fld id="{D1C87F3C-6FA4-D54F-AEDE-BC3ADE73DCD6}" type="datetimeFigureOut">
               <a:rPr lang="en-US" smtClean="0"/>
-              <a:t>1/17/26</a:t>
+              <a:t>1/18/26</a:t>
             </a:fld>
             <a:endParaRPr lang="en-US"/>
           </a:p>
@@ -3453,7 +3453,7 @@
           <a:p>
             <a:fld id="{D1C87F3C-6FA4-D54F-AEDE-BC3ADE73DCD6}" type="datetimeFigureOut">
               <a:rPr lang="en-US" smtClean="0"/>
-              <a:t>1/17/26</a:t>
+              <a:t>1/18/26</a:t>
             </a:fld>
             <a:endParaRPr lang="en-US"/>
           </a:p>
@@ -3710,7 +3710,7 @@
           <a:p>
             <a:fld id="{D1C87F3C-6FA4-D54F-AEDE-BC3ADE73DCD6}" type="datetimeFigureOut">
               <a:rPr lang="en-US" smtClean="0"/>
-              <a:t>1/17/26</a:t>
+              <a:t>1/18/26</a:t>
             </a:fld>
             <a:endParaRPr lang="en-US"/>
           </a:p>
@@ -3923,7 +3923,7 @@
           <a:p>
             <a:fld id="{D1C87F3C-6FA4-D54F-AEDE-BC3ADE73DCD6}" type="datetimeFigureOut">
               <a:rPr lang="en-US" smtClean="0"/>
-              <a:t>1/17/26</a:t>
+              <a:t>1/18/26</a:t>
             </a:fld>
             <a:endParaRPr lang="en-US"/>
           </a:p>
@@ -8483,9 +8483,7 @@
             <a:avLst/>
           </a:prstGeom>
           <a:solidFill>
-            <a:schemeClr val="bg1">
-              <a:lumMod val="65000"/>
-            </a:schemeClr>
+            <a:srgbClr val="4F6D8C"/>
           </a:solidFill>
           <a:ln>
             <a:noFill/>
@@ -8537,9 +8535,7 @@
             <a:avLst/>
           </a:prstGeom>
           <a:solidFill>
-            <a:schemeClr val="bg1">
-              <a:lumMod val="65000"/>
-            </a:schemeClr>
+            <a:srgbClr val="4F6D8C"/>
           </a:solidFill>
           <a:ln>
             <a:noFill/>
@@ -8591,9 +8587,7 @@
             <a:avLst/>
           </a:prstGeom>
           <a:solidFill>
-            <a:schemeClr val="bg1">
-              <a:lumMod val="65000"/>
-            </a:schemeClr>
+            <a:srgbClr val="C98A44"/>
           </a:solidFill>
           <a:ln>
             <a:noFill/>

</xml_diff>